<commit_message>
Add technical proposal and delivery roadmap
Co-authored-by: Fred Alberto Tembe <Fredalbertomoz@gmail.com>
</commit_message>
<xml_diff>
--- a/docs/sistema-gestao-ginasio-apresentacao.pptx
+++ b/docs/sistema-gestao-ginasio-apresentacao.pptx
@@ -23,6 +23,8 @@
     <p:sldId id="271" r:id="rId22"/>
     <p:sldId id="272" r:id="rId23"/>
     <p:sldId id="273" r:id="rId24"/>
+    <p:sldId id="274" r:id="rId25"/>
+    <p:sldId id="275" r:id="rId26"/>
   </p:sldIdLst>
   <p:sldSz cx="12191695" cy="6858000" type="screen4x3"/>
   <p:notesSz cx="6858000" cy="9144000"/>
@@ -9923,6 +9925,689 @@
 </p:sld>
 </file>
 
+<file path=ppt/slides/slide19.xml><?xml version="1.0" encoding="utf-8"?>
+<p:sld xmlns:a="http://schemas.openxmlformats.org/drawingml/2006/main" xmlns:p="http://schemas.openxmlformats.org/presentationml/2006/main" xmlns:r="http://schemas.openxmlformats.org/officeDocument/2006/relationships">
+  <p:cSld>
+    <p:bg>
+      <p:bgPr>
+        <a:solidFill>
+          <a:srgbClr val="F4F8FB"/>
+        </a:solidFill>
+        <a:effectLst/>
+      </p:bgPr>
+    </p:bg>
+    <p:spTree>
+      <p:nvGrpSpPr>
+        <p:cNvPr id="1" name=""/>
+        <p:cNvGrpSpPr/>
+        <p:nvPr/>
+      </p:nvGrpSpPr>
+      <p:grpSpPr/>
+      <p:sp>
+        <p:nvSpPr>
+          <p:cNvPr id="2" name="TextBox 1"/>
+          <p:cNvSpPr txBox="1"/>
+          <p:nvPr/>
+        </p:nvSpPr>
+        <p:spPr>
+          <a:xfrm>
+            <a:off x="640080" y="320040"/>
+            <a:ext cx="10881360" cy="594360"/>
+          </a:xfrm>
+          <a:prstGeom prst="rect">
+            <a:avLst/>
+          </a:prstGeom>
+          <a:noFill/>
+        </p:spPr>
+        <p:txBody>
+          <a:bodyPr wrap="none">
+            <a:spAutoFit/>
+          </a:bodyPr>
+          <a:lstStyle/>
+          <a:p>
+            <a:pPr algn="l"/>
+            <a:r>
+              <a:rPr sz="3000" b="1">
+                <a:solidFill>
+                  <a:srgbClr val="0E2340"/>
+                </a:solidFill>
+                <a:latin typeface="Aptos"/>
+              </a:rPr>
+              <a:t>Roadmap por etapas</a:t>
+            </a:r>
+          </a:p>
+        </p:txBody>
+      </p:sp>
+      <p:sp>
+        <p:nvSpPr>
+          <p:cNvPr id="3" name="TextBox 2"/>
+          <p:cNvSpPr txBox="1"/>
+          <p:nvPr/>
+        </p:nvSpPr>
+        <p:spPr>
+          <a:xfrm>
+            <a:off x="658368" y="932688"/>
+            <a:ext cx="10424160" cy="320040"/>
+          </a:xfrm>
+          <a:prstGeom prst="rect">
+            <a:avLst/>
+          </a:prstGeom>
+          <a:noFill/>
+        </p:spPr>
+        <p:txBody>
+          <a:bodyPr wrap="none">
+            <a:spAutoFit/>
+          </a:bodyPr>
+          <a:lstStyle/>
+          <a:p>
+            <a:pPr algn="l"/>
+            <a:r>
+              <a:rPr sz="1300" b="0">
+                <a:solidFill>
+                  <a:srgbClr val="687480"/>
+                </a:solidFill>
+                <a:latin typeface="Aptos"/>
+              </a:rPr>
+              <a:t>Evolução planejada do sistema</a:t>
+            </a:r>
+          </a:p>
+        </p:txBody>
+      </p:sp>
+      <p:sp>
+        <p:nvSpPr>
+          <p:cNvPr id="4" name="Rectangle 3"/>
+          <p:cNvSpPr/>
+          <p:nvPr/>
+        </p:nvSpPr>
+        <p:spPr>
+          <a:xfrm>
+            <a:off x="640080" y="1325880"/>
+            <a:ext cx="1143000" cy="54864"/>
+          </a:xfrm>
+          <a:prstGeom prst="rect">
+            <a:avLst/>
+          </a:prstGeom>
+          <a:solidFill>
+            <a:srgbClr val="00AEC7"/>
+          </a:solidFill>
+          <a:ln>
+            <a:noFill/>
+          </a:ln>
+        </p:spPr>
+        <p:style>
+          <a:lnRef idx="1">
+            <a:schemeClr val="accent1"/>
+          </a:lnRef>
+          <a:fillRef idx="3">
+            <a:schemeClr val="accent1"/>
+          </a:fillRef>
+          <a:effectRef idx="2">
+            <a:schemeClr val="accent1"/>
+          </a:effectRef>
+          <a:fontRef idx="minor">
+            <a:schemeClr val="lt1"/>
+          </a:fontRef>
+        </p:style>
+        <p:txBody>
+          <a:bodyPr rtlCol="0" anchor="ctr"/>
+          <a:lstStyle/>
+          <a:p>
+            <a:pPr algn="ctr"/>
+          </a:p>
+        </p:txBody>
+      </p:sp>
+      <p:sp>
+        <p:nvSpPr>
+          <p:cNvPr id="5" name="Rounded Rectangle 4"/>
+          <p:cNvSpPr/>
+          <p:nvPr/>
+        </p:nvSpPr>
+        <p:spPr>
+          <a:xfrm>
+            <a:off x="777240" y="1737360"/>
+            <a:ext cx="3520440" cy="2057400"/>
+          </a:xfrm>
+          <a:prstGeom prst="roundRect">
+            <a:avLst/>
+          </a:prstGeom>
+          <a:solidFill>
+            <a:srgbClr val="FFFFFF"/>
+          </a:solidFill>
+          <a:ln w="12700">
+            <a:solidFill>
+              <a:srgbClr val="DAE5EE"/>
+            </a:solidFill>
+          </a:ln>
+        </p:spPr>
+        <p:style>
+          <a:lnRef idx="1">
+            <a:schemeClr val="accent1"/>
+          </a:lnRef>
+          <a:fillRef idx="3">
+            <a:schemeClr val="accent1"/>
+          </a:fillRef>
+          <a:effectRef idx="2">
+            <a:schemeClr val="accent1"/>
+          </a:effectRef>
+          <a:fontRef idx="minor">
+            <a:schemeClr val="lt1"/>
+          </a:fontRef>
+        </p:style>
+        <p:txBody>
+          <a:bodyPr rtlCol="0" anchor="ctr"/>
+          <a:lstStyle/>
+          <a:p>
+            <a:pPr algn="ctr"/>
+          </a:p>
+        </p:txBody>
+      </p:sp>
+      <p:sp>
+        <p:nvSpPr>
+          <p:cNvPr id="6" name="Rounded Rectangle 5"/>
+          <p:cNvSpPr/>
+          <p:nvPr/>
+        </p:nvSpPr>
+        <p:spPr>
+          <a:xfrm>
+            <a:off x="777240" y="1737360"/>
+            <a:ext cx="109728" cy="2057400"/>
+          </a:xfrm>
+          <a:prstGeom prst="roundRect">
+            <a:avLst/>
+          </a:prstGeom>
+          <a:solidFill>
+            <a:srgbClr val="2170B5"/>
+          </a:solidFill>
+          <a:ln>
+            <a:noFill/>
+          </a:ln>
+        </p:spPr>
+        <p:style>
+          <a:lnRef idx="1">
+            <a:schemeClr val="accent1"/>
+          </a:lnRef>
+          <a:fillRef idx="3">
+            <a:schemeClr val="accent1"/>
+          </a:fillRef>
+          <a:effectRef idx="2">
+            <a:schemeClr val="accent1"/>
+          </a:effectRef>
+          <a:fontRef idx="minor">
+            <a:schemeClr val="lt1"/>
+          </a:fontRef>
+        </p:style>
+        <p:txBody>
+          <a:bodyPr rtlCol="0" anchor="ctr"/>
+          <a:lstStyle/>
+          <a:p>
+            <a:pPr algn="ctr"/>
+          </a:p>
+        </p:txBody>
+      </p:sp>
+      <p:sp>
+        <p:nvSpPr>
+          <p:cNvPr id="7" name="TextBox 6"/>
+          <p:cNvSpPr txBox="1"/>
+          <p:nvPr/>
+        </p:nvSpPr>
+        <p:spPr>
+          <a:xfrm>
+            <a:off x="978408" y="1901952"/>
+            <a:ext cx="3200400" cy="292608"/>
+          </a:xfrm>
+          <a:prstGeom prst="rect">
+            <a:avLst/>
+          </a:prstGeom>
+          <a:noFill/>
+        </p:spPr>
+        <p:txBody>
+          <a:bodyPr wrap="none">
+            <a:spAutoFit/>
+          </a:bodyPr>
+          <a:lstStyle/>
+          <a:p>
+            <a:pPr algn="l"/>
+            <a:r>
+              <a:rPr sz="1600" b="1">
+                <a:solidFill>
+                  <a:srgbClr val="0E2340"/>
+                </a:solidFill>
+                <a:latin typeface="Aptos"/>
+              </a:rPr>
+              <a:t>Etapa 1 - Desktop base</a:t>
+            </a:r>
+          </a:p>
+        </p:txBody>
+      </p:sp>
+      <p:sp>
+        <p:nvSpPr>
+          <p:cNvPr id="8" name="TextBox 7"/>
+          <p:cNvSpPr txBox="1"/>
+          <p:nvPr/>
+        </p:nvSpPr>
+        <p:spPr>
+          <a:xfrm>
+            <a:off x="978408" y="2331720"/>
+            <a:ext cx="3200400" cy="1344168"/>
+          </a:xfrm>
+          <a:prstGeom prst="rect">
+            <a:avLst/>
+          </a:prstGeom>
+          <a:noFill/>
+        </p:spPr>
+        <p:txBody>
+          <a:bodyPr wrap="none">
+            <a:spAutoFit/>
+          </a:bodyPr>
+          <a:lstStyle/>
+          <a:p>
+            <a:pPr algn="l"/>
+            <a:r>
+              <a:rPr sz="1200" b="0">
+                <a:solidFill>
+                  <a:srgbClr val="28313B"/>
+                </a:solidFill>
+                <a:latin typeface="Aptos"/>
+              </a:rPr>
+              <a:t>Sistema desktop operacional, sem CRM, sem Web API, sem mobile e sem integração com outros ginásios. Inclui backup na nuvem.</a:t>
+            </a:r>
+          </a:p>
+        </p:txBody>
+      </p:sp>
+      <p:sp>
+        <p:nvSpPr>
+          <p:cNvPr id="9" name="Rounded Rectangle 8"/>
+          <p:cNvSpPr/>
+          <p:nvPr/>
+        </p:nvSpPr>
+        <p:spPr>
+          <a:xfrm>
+            <a:off x="4434840" y="1737360"/>
+            <a:ext cx="3520440" cy="2057400"/>
+          </a:xfrm>
+          <a:prstGeom prst="roundRect">
+            <a:avLst/>
+          </a:prstGeom>
+          <a:solidFill>
+            <a:srgbClr val="FFFFFF"/>
+          </a:solidFill>
+          <a:ln w="12700">
+            <a:solidFill>
+              <a:srgbClr val="DAE5EE"/>
+            </a:solidFill>
+          </a:ln>
+        </p:spPr>
+        <p:style>
+          <a:lnRef idx="1">
+            <a:schemeClr val="accent1"/>
+          </a:lnRef>
+          <a:fillRef idx="3">
+            <a:schemeClr val="accent1"/>
+          </a:fillRef>
+          <a:effectRef idx="2">
+            <a:schemeClr val="accent1"/>
+          </a:effectRef>
+          <a:fontRef idx="minor">
+            <a:schemeClr val="lt1"/>
+          </a:fontRef>
+        </p:style>
+        <p:txBody>
+          <a:bodyPr rtlCol="0" anchor="ctr"/>
+          <a:lstStyle/>
+          <a:p>
+            <a:pPr algn="ctr"/>
+          </a:p>
+        </p:txBody>
+      </p:sp>
+      <p:sp>
+        <p:nvSpPr>
+          <p:cNvPr id="10" name="Rounded Rectangle 9"/>
+          <p:cNvSpPr/>
+          <p:nvPr/>
+        </p:nvSpPr>
+        <p:spPr>
+          <a:xfrm>
+            <a:off x="4434840" y="1737360"/>
+            <a:ext cx="109728" cy="2057400"/>
+          </a:xfrm>
+          <a:prstGeom prst="roundRect">
+            <a:avLst/>
+          </a:prstGeom>
+          <a:solidFill>
+            <a:srgbClr val="26A65B"/>
+          </a:solidFill>
+          <a:ln>
+            <a:noFill/>
+          </a:ln>
+        </p:spPr>
+        <p:style>
+          <a:lnRef idx="1">
+            <a:schemeClr val="accent1"/>
+          </a:lnRef>
+          <a:fillRef idx="3">
+            <a:schemeClr val="accent1"/>
+          </a:fillRef>
+          <a:effectRef idx="2">
+            <a:schemeClr val="accent1"/>
+          </a:effectRef>
+          <a:fontRef idx="minor">
+            <a:schemeClr val="lt1"/>
+          </a:fontRef>
+        </p:style>
+        <p:txBody>
+          <a:bodyPr rtlCol="0" anchor="ctr"/>
+          <a:lstStyle/>
+          <a:p>
+            <a:pPr algn="ctr"/>
+          </a:p>
+        </p:txBody>
+      </p:sp>
+      <p:sp>
+        <p:nvSpPr>
+          <p:cNvPr id="11" name="TextBox 10"/>
+          <p:cNvSpPr txBox="1"/>
+          <p:nvPr/>
+        </p:nvSpPr>
+        <p:spPr>
+          <a:xfrm>
+            <a:off x="4636007" y="1901952"/>
+            <a:ext cx="3200400" cy="292608"/>
+          </a:xfrm>
+          <a:prstGeom prst="rect">
+            <a:avLst/>
+          </a:prstGeom>
+          <a:noFill/>
+        </p:spPr>
+        <p:txBody>
+          <a:bodyPr wrap="none">
+            <a:spAutoFit/>
+          </a:bodyPr>
+          <a:lstStyle/>
+          <a:p>
+            <a:pPr algn="l"/>
+            <a:r>
+              <a:rPr sz="1600" b="1">
+                <a:solidFill>
+                  <a:srgbClr val="0E2340"/>
+                </a:solidFill>
+                <a:latin typeface="Aptos"/>
+              </a:rPr>
+              <a:t>Etapa 2 - Web + CRM</a:t>
+            </a:r>
+          </a:p>
+        </p:txBody>
+      </p:sp>
+      <p:sp>
+        <p:nvSpPr>
+          <p:cNvPr id="12" name="TextBox 11"/>
+          <p:cNvSpPr txBox="1"/>
+          <p:nvPr/>
+        </p:nvSpPr>
+        <p:spPr>
+          <a:xfrm>
+            <a:off x="4636007" y="2331720"/>
+            <a:ext cx="3200400" cy="1344168"/>
+          </a:xfrm>
+          <a:prstGeom prst="rect">
+            <a:avLst/>
+          </a:prstGeom>
+          <a:noFill/>
+        </p:spPr>
+        <p:txBody>
+          <a:bodyPr wrap="none">
+            <a:spAutoFit/>
+          </a:bodyPr>
+          <a:lstStyle/>
+          <a:p>
+            <a:pPr algn="l"/>
+            <a:r>
+              <a:rPr sz="1200" b="0">
+                <a:solidFill>
+                  <a:srgbClr val="28313B"/>
+                </a:solidFill>
+                <a:latin typeface="Aptos"/>
+              </a:rPr>
+              <a:t>Web API, painel web para monitoramento remoto, sincronização, CRM, campanhas, bónus e SMS.</a:t>
+            </a:r>
+          </a:p>
+        </p:txBody>
+      </p:sp>
+      <p:sp>
+        <p:nvSpPr>
+          <p:cNvPr id="13" name="Rounded Rectangle 12"/>
+          <p:cNvSpPr/>
+          <p:nvPr/>
+        </p:nvSpPr>
+        <p:spPr>
+          <a:xfrm>
+            <a:off x="8092440" y="1737360"/>
+            <a:ext cx="3520440" cy="2057400"/>
+          </a:xfrm>
+          <a:prstGeom prst="roundRect">
+            <a:avLst/>
+          </a:prstGeom>
+          <a:solidFill>
+            <a:srgbClr val="FFFFFF"/>
+          </a:solidFill>
+          <a:ln w="12700">
+            <a:solidFill>
+              <a:srgbClr val="DAE5EE"/>
+            </a:solidFill>
+          </a:ln>
+        </p:spPr>
+        <p:style>
+          <a:lnRef idx="1">
+            <a:schemeClr val="accent1"/>
+          </a:lnRef>
+          <a:fillRef idx="3">
+            <a:schemeClr val="accent1"/>
+          </a:fillRef>
+          <a:effectRef idx="2">
+            <a:schemeClr val="accent1"/>
+          </a:effectRef>
+          <a:fontRef idx="minor">
+            <a:schemeClr val="lt1"/>
+          </a:fontRef>
+        </p:style>
+        <p:txBody>
+          <a:bodyPr rtlCol="0" anchor="ctr"/>
+          <a:lstStyle/>
+          <a:p>
+            <a:pPr algn="ctr"/>
+          </a:p>
+        </p:txBody>
+      </p:sp>
+      <p:sp>
+        <p:nvSpPr>
+          <p:cNvPr id="14" name="Rounded Rectangle 13"/>
+          <p:cNvSpPr/>
+          <p:nvPr/>
+        </p:nvSpPr>
+        <p:spPr>
+          <a:xfrm>
+            <a:off x="8092440" y="1737360"/>
+            <a:ext cx="109728" cy="2057400"/>
+          </a:xfrm>
+          <a:prstGeom prst="roundRect">
+            <a:avLst/>
+          </a:prstGeom>
+          <a:solidFill>
+            <a:srgbClr val="F19430"/>
+          </a:solidFill>
+          <a:ln>
+            <a:noFill/>
+          </a:ln>
+        </p:spPr>
+        <p:style>
+          <a:lnRef idx="1">
+            <a:schemeClr val="accent1"/>
+          </a:lnRef>
+          <a:fillRef idx="3">
+            <a:schemeClr val="accent1"/>
+          </a:fillRef>
+          <a:effectRef idx="2">
+            <a:schemeClr val="accent1"/>
+          </a:effectRef>
+          <a:fontRef idx="minor">
+            <a:schemeClr val="lt1"/>
+          </a:fontRef>
+        </p:style>
+        <p:txBody>
+          <a:bodyPr rtlCol="0" anchor="ctr"/>
+          <a:lstStyle/>
+          <a:p>
+            <a:pPr algn="ctr"/>
+          </a:p>
+        </p:txBody>
+      </p:sp>
+      <p:sp>
+        <p:nvSpPr>
+          <p:cNvPr id="15" name="TextBox 14"/>
+          <p:cNvSpPr txBox="1"/>
+          <p:nvPr/>
+        </p:nvSpPr>
+        <p:spPr>
+          <a:xfrm>
+            <a:off x="8293608" y="1901952"/>
+            <a:ext cx="3200400" cy="292608"/>
+          </a:xfrm>
+          <a:prstGeom prst="rect">
+            <a:avLst/>
+          </a:prstGeom>
+          <a:noFill/>
+        </p:spPr>
+        <p:txBody>
+          <a:bodyPr wrap="none">
+            <a:spAutoFit/>
+          </a:bodyPr>
+          <a:lstStyle/>
+          <a:p>
+            <a:pPr algn="l"/>
+            <a:r>
+              <a:rPr sz="1600" b="1">
+                <a:solidFill>
+                  <a:srgbClr val="0E2340"/>
+                </a:solidFill>
+                <a:latin typeface="Aptos"/>
+              </a:rPr>
+              <a:t>Etapa 3 - Mobile</a:t>
+            </a:r>
+          </a:p>
+        </p:txBody>
+      </p:sp>
+      <p:sp>
+        <p:nvSpPr>
+          <p:cNvPr id="16" name="TextBox 15"/>
+          <p:cNvSpPr txBox="1"/>
+          <p:nvPr/>
+        </p:nvSpPr>
+        <p:spPr>
+          <a:xfrm>
+            <a:off x="8293608" y="2331720"/>
+            <a:ext cx="3200400" cy="1344168"/>
+          </a:xfrm>
+          <a:prstGeom prst="rect">
+            <a:avLst/>
+          </a:prstGeom>
+          <a:noFill/>
+        </p:spPr>
+        <p:txBody>
+          <a:bodyPr wrap="none">
+            <a:spAutoFit/>
+          </a:bodyPr>
+          <a:lstStyle/>
+          <a:p>
+            <a:pPr algn="l"/>
+            <a:r>
+              <a:rPr sz="1200" b="0">
+                <a:solidFill>
+                  <a:srgbClr val="28313B"/>
+                </a:solidFill>
+                <a:latin typeface="Aptos"/>
+              </a:rPr>
+              <a:t>App mobile para utentes visualizarem contrato, pagamentos, acessos, evolução física, bónus e notificações.</a:t>
+            </a:r>
+          </a:p>
+        </p:txBody>
+      </p:sp>
+      <p:sp>
+        <p:nvSpPr>
+          <p:cNvPr id="17" name="TextBox 16"/>
+          <p:cNvSpPr txBox="1"/>
+          <p:nvPr/>
+        </p:nvSpPr>
+        <p:spPr>
+          <a:xfrm>
+            <a:off x="914400" y="4754880"/>
+            <a:ext cx="10241280" cy="640080"/>
+          </a:xfrm>
+          <a:prstGeom prst="rect">
+            <a:avLst/>
+          </a:prstGeom>
+          <a:noFill/>
+        </p:spPr>
+        <p:txBody>
+          <a:bodyPr wrap="none">
+            <a:spAutoFit/>
+          </a:bodyPr>
+          <a:lstStyle/>
+          <a:p>
+            <a:pPr algn="ctr"/>
+            <a:r>
+              <a:rPr sz="1900" b="1">
+                <a:solidFill>
+                  <a:srgbClr val="0E2340"/>
+                </a:solidFill>
+                <a:latin typeface="Aptos"/>
+              </a:rPr>
+              <a:t>A estratégia reduz risco: primeiro entrega operação local, depois gestão remota e por fim experiência mobile para o utente.</a:t>
+            </a:r>
+          </a:p>
+        </p:txBody>
+      </p:sp>
+      <p:sp>
+        <p:nvSpPr>
+          <p:cNvPr id="18" name="TextBox 17"/>
+          <p:cNvSpPr txBox="1"/>
+          <p:nvPr/>
+        </p:nvSpPr>
+        <p:spPr>
+          <a:xfrm>
+            <a:off x="11384280" y="6446520"/>
+            <a:ext cx="411480" cy="228600"/>
+          </a:xfrm>
+          <a:prstGeom prst="rect">
+            <a:avLst/>
+          </a:prstGeom>
+          <a:noFill/>
+        </p:spPr>
+        <p:txBody>
+          <a:bodyPr wrap="none">
+            <a:spAutoFit/>
+          </a:bodyPr>
+          <a:lstStyle/>
+          <a:p>
+            <a:pPr algn="r"/>
+            <a:r>
+              <a:rPr sz="900" b="0">
+                <a:solidFill>
+                  <a:srgbClr val="687480"/>
+                </a:solidFill>
+                <a:latin typeface="Aptos"/>
+              </a:rPr>
+              <a:t>19</a:t>
+            </a:r>
+          </a:p>
+        </p:txBody>
+      </p:sp>
+    </p:spTree>
+  </p:cSld>
+  <p:clrMapOvr>
+    <a:masterClrMapping/>
+  </p:clrMapOvr>
+</p:sld>
+</file>
+
 <file path=ppt/slides/slide2.xml><?xml version="1.0" encoding="utf-8"?>
 <p:sld xmlns:a="http://schemas.openxmlformats.org/drawingml/2006/main" xmlns:p="http://schemas.openxmlformats.org/presentationml/2006/main" xmlns:r="http://schemas.openxmlformats.org/officeDocument/2006/relationships">
   <p:cSld>
@@ -10594,6 +11279,903 @@
                 <a:latin typeface="Aptos"/>
               </a:rPr>
               <a:t>02</a:t>
+            </a:r>
+          </a:p>
+        </p:txBody>
+      </p:sp>
+    </p:spTree>
+  </p:cSld>
+  <p:clrMapOvr>
+    <a:masterClrMapping/>
+  </p:clrMapOvr>
+</p:sld>
+</file>
+
+<file path=ppt/slides/slide20.xml><?xml version="1.0" encoding="utf-8"?>
+<p:sld xmlns:a="http://schemas.openxmlformats.org/drawingml/2006/main" xmlns:p="http://schemas.openxmlformats.org/presentationml/2006/main" xmlns:r="http://schemas.openxmlformats.org/officeDocument/2006/relationships">
+  <p:cSld>
+    <p:bg>
+      <p:bgPr>
+        <a:solidFill>
+          <a:srgbClr val="F4F8FB"/>
+        </a:solidFill>
+        <a:effectLst/>
+      </p:bgPr>
+    </p:bg>
+    <p:spTree>
+      <p:nvGrpSpPr>
+        <p:cNvPr id="1" name=""/>
+        <p:cNvGrpSpPr/>
+        <p:nvPr/>
+      </p:nvGrpSpPr>
+      <p:grpSpPr/>
+      <p:sp>
+        <p:nvSpPr>
+          <p:cNvPr id="2" name="TextBox 1"/>
+          <p:cNvSpPr txBox="1"/>
+          <p:nvPr/>
+        </p:nvSpPr>
+        <p:spPr>
+          <a:xfrm>
+            <a:off x="640080" y="320040"/>
+            <a:ext cx="10881360" cy="594360"/>
+          </a:xfrm>
+          <a:prstGeom prst="rect">
+            <a:avLst/>
+          </a:prstGeom>
+          <a:noFill/>
+        </p:spPr>
+        <p:txBody>
+          <a:bodyPr wrap="none">
+            <a:spAutoFit/>
+          </a:bodyPr>
+          <a:lstStyle/>
+          <a:p>
+            <a:pPr algn="l"/>
+            <a:r>
+              <a:rPr sz="3000" b="1">
+                <a:solidFill>
+                  <a:srgbClr val="0E2340"/>
+                </a:solidFill>
+                <a:latin typeface="Aptos"/>
+              </a:rPr>
+              <a:t>Estimativa considerando base existente</a:t>
+            </a:r>
+          </a:p>
+        </p:txBody>
+      </p:sp>
+      <p:sp>
+        <p:nvSpPr>
+          <p:cNvPr id="3" name="TextBox 2"/>
+          <p:cNvSpPr txBox="1"/>
+          <p:nvPr/>
+        </p:nvSpPr>
+        <p:spPr>
+          <a:xfrm>
+            <a:off x="658368" y="932688"/>
+            <a:ext cx="10424160" cy="320040"/>
+          </a:xfrm>
+          <a:prstGeom prst="rect">
+            <a:avLst/>
+          </a:prstGeom>
+          <a:noFill/>
+        </p:spPr>
+        <p:txBody>
+          <a:bodyPr wrap="none">
+            <a:spAutoFit/>
+          </a:bodyPr>
+          <a:lstStyle/>
+          <a:p>
+            <a:pPr algn="l"/>
+            <a:r>
+              <a:rPr sz="1300" b="0">
+                <a:solidFill>
+                  <a:srgbClr val="687480"/>
+                </a:solidFill>
+                <a:latin typeface="Aptos"/>
+              </a:rPr>
+              <a:t>Cenário: arquitetura limpa e UI WPF já disponíveis</a:t>
+            </a:r>
+          </a:p>
+        </p:txBody>
+      </p:sp>
+      <p:sp>
+        <p:nvSpPr>
+          <p:cNvPr id="4" name="Rectangle 3"/>
+          <p:cNvSpPr/>
+          <p:nvPr/>
+        </p:nvSpPr>
+        <p:spPr>
+          <a:xfrm>
+            <a:off x="640080" y="1325880"/>
+            <a:ext cx="1143000" cy="54864"/>
+          </a:xfrm>
+          <a:prstGeom prst="rect">
+            <a:avLst/>
+          </a:prstGeom>
+          <a:solidFill>
+            <a:srgbClr val="00AEC7"/>
+          </a:solidFill>
+          <a:ln>
+            <a:noFill/>
+          </a:ln>
+        </p:spPr>
+        <p:style>
+          <a:lnRef idx="1">
+            <a:schemeClr val="accent1"/>
+          </a:lnRef>
+          <a:fillRef idx="3">
+            <a:schemeClr val="accent1"/>
+          </a:fillRef>
+          <a:effectRef idx="2">
+            <a:schemeClr val="accent1"/>
+          </a:effectRef>
+          <a:fontRef idx="minor">
+            <a:schemeClr val="lt1"/>
+          </a:fontRef>
+        </p:style>
+        <p:txBody>
+          <a:bodyPr rtlCol="0" anchor="ctr"/>
+          <a:lstStyle/>
+          <a:p>
+            <a:pPr algn="ctr"/>
+          </a:p>
+        </p:txBody>
+      </p:sp>
+      <p:sp>
+        <p:nvSpPr>
+          <p:cNvPr id="5" name="Rounded Rectangle 4"/>
+          <p:cNvSpPr/>
+          <p:nvPr/>
+        </p:nvSpPr>
+        <p:spPr>
+          <a:xfrm>
+            <a:off x="822960" y="1737360"/>
+            <a:ext cx="2651760" cy="1645920"/>
+          </a:xfrm>
+          <a:prstGeom prst="roundRect">
+            <a:avLst/>
+          </a:prstGeom>
+          <a:solidFill>
+            <a:srgbClr val="FFFFFF"/>
+          </a:solidFill>
+          <a:ln w="12700">
+            <a:solidFill>
+              <a:srgbClr val="DAE5EE"/>
+            </a:solidFill>
+          </a:ln>
+        </p:spPr>
+        <p:style>
+          <a:lnRef idx="1">
+            <a:schemeClr val="accent1"/>
+          </a:lnRef>
+          <a:fillRef idx="3">
+            <a:schemeClr val="accent1"/>
+          </a:fillRef>
+          <a:effectRef idx="2">
+            <a:schemeClr val="accent1"/>
+          </a:effectRef>
+          <a:fontRef idx="minor">
+            <a:schemeClr val="lt1"/>
+          </a:fontRef>
+        </p:style>
+        <p:txBody>
+          <a:bodyPr rtlCol="0" anchor="ctr"/>
+          <a:lstStyle/>
+          <a:p>
+            <a:pPr algn="ctr"/>
+          </a:p>
+        </p:txBody>
+      </p:sp>
+      <p:sp>
+        <p:nvSpPr>
+          <p:cNvPr id="6" name="Rounded Rectangle 5"/>
+          <p:cNvSpPr/>
+          <p:nvPr/>
+        </p:nvSpPr>
+        <p:spPr>
+          <a:xfrm>
+            <a:off x="822960" y="1737360"/>
+            <a:ext cx="109728" cy="1645920"/>
+          </a:xfrm>
+          <a:prstGeom prst="roundRect">
+            <a:avLst/>
+          </a:prstGeom>
+          <a:solidFill>
+            <a:srgbClr val="2170B5"/>
+          </a:solidFill>
+          <a:ln>
+            <a:noFill/>
+          </a:ln>
+        </p:spPr>
+        <p:style>
+          <a:lnRef idx="1">
+            <a:schemeClr val="accent1"/>
+          </a:lnRef>
+          <a:fillRef idx="3">
+            <a:schemeClr val="accent1"/>
+          </a:fillRef>
+          <a:effectRef idx="2">
+            <a:schemeClr val="accent1"/>
+          </a:effectRef>
+          <a:fontRef idx="minor">
+            <a:schemeClr val="lt1"/>
+          </a:fontRef>
+        </p:style>
+        <p:txBody>
+          <a:bodyPr rtlCol="0" anchor="ctr"/>
+          <a:lstStyle/>
+          <a:p>
+            <a:pPr algn="ctr"/>
+          </a:p>
+        </p:txBody>
+      </p:sp>
+      <p:sp>
+        <p:nvSpPr>
+          <p:cNvPr id="7" name="TextBox 6"/>
+          <p:cNvSpPr txBox="1"/>
+          <p:nvPr/>
+        </p:nvSpPr>
+        <p:spPr>
+          <a:xfrm>
+            <a:off x="1024128" y="1901952"/>
+            <a:ext cx="2331720" cy="292608"/>
+          </a:xfrm>
+          <a:prstGeom prst="rect">
+            <a:avLst/>
+          </a:prstGeom>
+          <a:noFill/>
+        </p:spPr>
+        <p:txBody>
+          <a:bodyPr wrap="none">
+            <a:spAutoFit/>
+          </a:bodyPr>
+          <a:lstStyle/>
+          <a:p>
+            <a:pPr algn="l"/>
+            <a:r>
+              <a:rPr sz="1800" b="1">
+                <a:solidFill>
+                  <a:srgbClr val="0E2340"/>
+                </a:solidFill>
+                <a:latin typeface="Aptos"/>
+              </a:rPr>
+              <a:t>Etapa 1</a:t>
+            </a:r>
+          </a:p>
+        </p:txBody>
+      </p:sp>
+      <p:sp>
+        <p:nvSpPr>
+          <p:cNvPr id="8" name="TextBox 7"/>
+          <p:cNvSpPr txBox="1"/>
+          <p:nvPr/>
+        </p:nvSpPr>
+        <p:spPr>
+          <a:xfrm>
+            <a:off x="1024128" y="2331720"/>
+            <a:ext cx="2331720" cy="932688"/>
+          </a:xfrm>
+          <a:prstGeom prst="rect">
+            <a:avLst/>
+          </a:prstGeom>
+          <a:noFill/>
+        </p:spPr>
+        <p:txBody>
+          <a:bodyPr wrap="none">
+            <a:spAutoFit/>
+          </a:bodyPr>
+          <a:lstStyle/>
+          <a:p>
+            <a:pPr algn="l"/>
+            <a:r>
+              <a:rPr sz="1500" b="0">
+                <a:solidFill>
+                  <a:srgbClr val="28313B"/>
+                </a:solidFill>
+                <a:latin typeface="Aptos"/>
+              </a:rPr>
+              <a:t>25 a 40 dias
+Desktop base + backup na nuvem</a:t>
+            </a:r>
+          </a:p>
+        </p:txBody>
+      </p:sp>
+      <p:sp>
+        <p:nvSpPr>
+          <p:cNvPr id="9" name="Rounded Rectangle 8"/>
+          <p:cNvSpPr/>
+          <p:nvPr/>
+        </p:nvSpPr>
+        <p:spPr>
+          <a:xfrm>
+            <a:off x="3611880" y="1737360"/>
+            <a:ext cx="2651760" cy="1645920"/>
+          </a:xfrm>
+          <a:prstGeom prst="roundRect">
+            <a:avLst/>
+          </a:prstGeom>
+          <a:solidFill>
+            <a:srgbClr val="FFFFFF"/>
+          </a:solidFill>
+          <a:ln w="12700">
+            <a:solidFill>
+              <a:srgbClr val="DAE5EE"/>
+            </a:solidFill>
+          </a:ln>
+        </p:spPr>
+        <p:style>
+          <a:lnRef idx="1">
+            <a:schemeClr val="accent1"/>
+          </a:lnRef>
+          <a:fillRef idx="3">
+            <a:schemeClr val="accent1"/>
+          </a:fillRef>
+          <a:effectRef idx="2">
+            <a:schemeClr val="accent1"/>
+          </a:effectRef>
+          <a:fontRef idx="minor">
+            <a:schemeClr val="lt1"/>
+          </a:fontRef>
+        </p:style>
+        <p:txBody>
+          <a:bodyPr rtlCol="0" anchor="ctr"/>
+          <a:lstStyle/>
+          <a:p>
+            <a:pPr algn="ctr"/>
+          </a:p>
+        </p:txBody>
+      </p:sp>
+      <p:sp>
+        <p:nvSpPr>
+          <p:cNvPr id="10" name="Rounded Rectangle 9"/>
+          <p:cNvSpPr/>
+          <p:nvPr/>
+        </p:nvSpPr>
+        <p:spPr>
+          <a:xfrm>
+            <a:off x="3611880" y="1737360"/>
+            <a:ext cx="109728" cy="1645920"/>
+          </a:xfrm>
+          <a:prstGeom prst="roundRect">
+            <a:avLst/>
+          </a:prstGeom>
+          <a:solidFill>
+            <a:srgbClr val="26A65B"/>
+          </a:solidFill>
+          <a:ln>
+            <a:noFill/>
+          </a:ln>
+        </p:spPr>
+        <p:style>
+          <a:lnRef idx="1">
+            <a:schemeClr val="accent1"/>
+          </a:lnRef>
+          <a:fillRef idx="3">
+            <a:schemeClr val="accent1"/>
+          </a:fillRef>
+          <a:effectRef idx="2">
+            <a:schemeClr val="accent1"/>
+          </a:effectRef>
+          <a:fontRef idx="minor">
+            <a:schemeClr val="lt1"/>
+          </a:fontRef>
+        </p:style>
+        <p:txBody>
+          <a:bodyPr rtlCol="0" anchor="ctr"/>
+          <a:lstStyle/>
+          <a:p>
+            <a:pPr algn="ctr"/>
+          </a:p>
+        </p:txBody>
+      </p:sp>
+      <p:sp>
+        <p:nvSpPr>
+          <p:cNvPr id="11" name="TextBox 10"/>
+          <p:cNvSpPr txBox="1"/>
+          <p:nvPr/>
+        </p:nvSpPr>
+        <p:spPr>
+          <a:xfrm>
+            <a:off x="3813048" y="1901952"/>
+            <a:ext cx="2331720" cy="292608"/>
+          </a:xfrm>
+          <a:prstGeom prst="rect">
+            <a:avLst/>
+          </a:prstGeom>
+          <a:noFill/>
+        </p:spPr>
+        <p:txBody>
+          <a:bodyPr wrap="none">
+            <a:spAutoFit/>
+          </a:bodyPr>
+          <a:lstStyle/>
+          <a:p>
+            <a:pPr algn="l"/>
+            <a:r>
+              <a:rPr sz="1800" b="1">
+                <a:solidFill>
+                  <a:srgbClr val="0E2340"/>
+                </a:solidFill>
+                <a:latin typeface="Aptos"/>
+              </a:rPr>
+              <a:t>Etapa 2</a:t>
+            </a:r>
+          </a:p>
+        </p:txBody>
+      </p:sp>
+      <p:sp>
+        <p:nvSpPr>
+          <p:cNvPr id="12" name="TextBox 11"/>
+          <p:cNvSpPr txBox="1"/>
+          <p:nvPr/>
+        </p:nvSpPr>
+        <p:spPr>
+          <a:xfrm>
+            <a:off x="3813048" y="2331720"/>
+            <a:ext cx="2331720" cy="932688"/>
+          </a:xfrm>
+          <a:prstGeom prst="rect">
+            <a:avLst/>
+          </a:prstGeom>
+          <a:noFill/>
+        </p:spPr>
+        <p:txBody>
+          <a:bodyPr wrap="none">
+            <a:spAutoFit/>
+          </a:bodyPr>
+          <a:lstStyle/>
+          <a:p>
+            <a:pPr algn="l"/>
+            <a:r>
+              <a:rPr sz="1500" b="0">
+                <a:solidFill>
+                  <a:srgbClr val="28313B"/>
+                </a:solidFill>
+                <a:latin typeface="Aptos"/>
+              </a:rPr>
+              <a:t>25 a 40 dias
+Web API + painel web + CRM</a:t>
+            </a:r>
+          </a:p>
+        </p:txBody>
+      </p:sp>
+      <p:sp>
+        <p:nvSpPr>
+          <p:cNvPr id="13" name="Rounded Rectangle 12"/>
+          <p:cNvSpPr/>
+          <p:nvPr/>
+        </p:nvSpPr>
+        <p:spPr>
+          <a:xfrm>
+            <a:off x="6400800" y="1737360"/>
+            <a:ext cx="2651760" cy="1645920"/>
+          </a:xfrm>
+          <a:prstGeom prst="roundRect">
+            <a:avLst/>
+          </a:prstGeom>
+          <a:solidFill>
+            <a:srgbClr val="FFFFFF"/>
+          </a:solidFill>
+          <a:ln w="12700">
+            <a:solidFill>
+              <a:srgbClr val="DAE5EE"/>
+            </a:solidFill>
+          </a:ln>
+        </p:spPr>
+        <p:style>
+          <a:lnRef idx="1">
+            <a:schemeClr val="accent1"/>
+          </a:lnRef>
+          <a:fillRef idx="3">
+            <a:schemeClr val="accent1"/>
+          </a:fillRef>
+          <a:effectRef idx="2">
+            <a:schemeClr val="accent1"/>
+          </a:effectRef>
+          <a:fontRef idx="minor">
+            <a:schemeClr val="lt1"/>
+          </a:fontRef>
+        </p:style>
+        <p:txBody>
+          <a:bodyPr rtlCol="0" anchor="ctr"/>
+          <a:lstStyle/>
+          <a:p>
+            <a:pPr algn="ctr"/>
+          </a:p>
+        </p:txBody>
+      </p:sp>
+      <p:sp>
+        <p:nvSpPr>
+          <p:cNvPr id="14" name="Rounded Rectangle 13"/>
+          <p:cNvSpPr/>
+          <p:nvPr/>
+        </p:nvSpPr>
+        <p:spPr>
+          <a:xfrm>
+            <a:off x="6400800" y="1737360"/>
+            <a:ext cx="109728" cy="1645920"/>
+          </a:xfrm>
+          <a:prstGeom prst="roundRect">
+            <a:avLst/>
+          </a:prstGeom>
+          <a:solidFill>
+            <a:srgbClr val="F19430"/>
+          </a:solidFill>
+          <a:ln>
+            <a:noFill/>
+          </a:ln>
+        </p:spPr>
+        <p:style>
+          <a:lnRef idx="1">
+            <a:schemeClr val="accent1"/>
+          </a:lnRef>
+          <a:fillRef idx="3">
+            <a:schemeClr val="accent1"/>
+          </a:fillRef>
+          <a:effectRef idx="2">
+            <a:schemeClr val="accent1"/>
+          </a:effectRef>
+          <a:fontRef idx="minor">
+            <a:schemeClr val="lt1"/>
+          </a:fontRef>
+        </p:style>
+        <p:txBody>
+          <a:bodyPr rtlCol="0" anchor="ctr"/>
+          <a:lstStyle/>
+          <a:p>
+            <a:pPr algn="ctr"/>
+          </a:p>
+        </p:txBody>
+      </p:sp>
+      <p:sp>
+        <p:nvSpPr>
+          <p:cNvPr id="15" name="TextBox 14"/>
+          <p:cNvSpPr txBox="1"/>
+          <p:nvPr/>
+        </p:nvSpPr>
+        <p:spPr>
+          <a:xfrm>
+            <a:off x="6601968" y="1901952"/>
+            <a:ext cx="2331720" cy="292608"/>
+          </a:xfrm>
+          <a:prstGeom prst="rect">
+            <a:avLst/>
+          </a:prstGeom>
+          <a:noFill/>
+        </p:spPr>
+        <p:txBody>
+          <a:bodyPr wrap="none">
+            <a:spAutoFit/>
+          </a:bodyPr>
+          <a:lstStyle/>
+          <a:p>
+            <a:pPr algn="l"/>
+            <a:r>
+              <a:rPr sz="1800" b="1">
+                <a:solidFill>
+                  <a:srgbClr val="0E2340"/>
+                </a:solidFill>
+                <a:latin typeface="Aptos"/>
+              </a:rPr>
+              <a:t>Etapa 3</a:t>
+            </a:r>
+          </a:p>
+        </p:txBody>
+      </p:sp>
+      <p:sp>
+        <p:nvSpPr>
+          <p:cNvPr id="16" name="TextBox 15"/>
+          <p:cNvSpPr txBox="1"/>
+          <p:nvPr/>
+        </p:nvSpPr>
+        <p:spPr>
+          <a:xfrm>
+            <a:off x="6601968" y="2331720"/>
+            <a:ext cx="2331720" cy="932688"/>
+          </a:xfrm>
+          <a:prstGeom prst="rect">
+            <a:avLst/>
+          </a:prstGeom>
+          <a:noFill/>
+        </p:spPr>
+        <p:txBody>
+          <a:bodyPr wrap="none">
+            <a:spAutoFit/>
+          </a:bodyPr>
+          <a:lstStyle/>
+          <a:p>
+            <a:pPr algn="l"/>
+            <a:r>
+              <a:rPr sz="1500" b="0">
+                <a:solidFill>
+                  <a:srgbClr val="28313B"/>
+                </a:solidFill>
+                <a:latin typeface="Aptos"/>
+              </a:rPr>
+              <a:t>20 a 30 dias
+App mobile para utentes</a:t>
+            </a:r>
+          </a:p>
+        </p:txBody>
+      </p:sp>
+      <p:sp>
+        <p:nvSpPr>
+          <p:cNvPr id="17" name="Rounded Rectangle 16"/>
+          <p:cNvSpPr/>
+          <p:nvPr/>
+        </p:nvSpPr>
+        <p:spPr>
+          <a:xfrm>
+            <a:off x="9189720" y="1737360"/>
+            <a:ext cx="2240280" cy="1645920"/>
+          </a:xfrm>
+          <a:prstGeom prst="roundRect">
+            <a:avLst/>
+          </a:prstGeom>
+          <a:solidFill>
+            <a:srgbClr val="FFFFFF"/>
+          </a:solidFill>
+          <a:ln w="12700">
+            <a:solidFill>
+              <a:srgbClr val="DAE5EE"/>
+            </a:solidFill>
+          </a:ln>
+        </p:spPr>
+        <p:style>
+          <a:lnRef idx="1">
+            <a:schemeClr val="accent1"/>
+          </a:lnRef>
+          <a:fillRef idx="3">
+            <a:schemeClr val="accent1"/>
+          </a:fillRef>
+          <a:effectRef idx="2">
+            <a:schemeClr val="accent1"/>
+          </a:effectRef>
+          <a:fontRef idx="minor">
+            <a:schemeClr val="lt1"/>
+          </a:fontRef>
+        </p:style>
+        <p:txBody>
+          <a:bodyPr rtlCol="0" anchor="ctr"/>
+          <a:lstStyle/>
+          <a:p>
+            <a:pPr algn="ctr"/>
+          </a:p>
+        </p:txBody>
+      </p:sp>
+      <p:sp>
+        <p:nvSpPr>
+          <p:cNvPr id="18" name="Rounded Rectangle 17"/>
+          <p:cNvSpPr/>
+          <p:nvPr/>
+        </p:nvSpPr>
+        <p:spPr>
+          <a:xfrm>
+            <a:off x="9189720" y="1737360"/>
+            <a:ext cx="109728" cy="1645920"/>
+          </a:xfrm>
+          <a:prstGeom prst="roundRect">
+            <a:avLst/>
+          </a:prstGeom>
+          <a:solidFill>
+            <a:srgbClr val="0E2340"/>
+          </a:solidFill>
+          <a:ln>
+            <a:noFill/>
+          </a:ln>
+        </p:spPr>
+        <p:style>
+          <a:lnRef idx="1">
+            <a:schemeClr val="accent1"/>
+          </a:lnRef>
+          <a:fillRef idx="3">
+            <a:schemeClr val="accent1"/>
+          </a:fillRef>
+          <a:effectRef idx="2">
+            <a:schemeClr val="accent1"/>
+          </a:effectRef>
+          <a:fontRef idx="minor">
+            <a:schemeClr val="lt1"/>
+          </a:fontRef>
+        </p:style>
+        <p:txBody>
+          <a:bodyPr rtlCol="0" anchor="ctr"/>
+          <a:lstStyle/>
+          <a:p>
+            <a:pPr algn="ctr"/>
+          </a:p>
+        </p:txBody>
+      </p:sp>
+      <p:sp>
+        <p:nvSpPr>
+          <p:cNvPr id="19" name="TextBox 18"/>
+          <p:cNvSpPr txBox="1"/>
+          <p:nvPr/>
+        </p:nvSpPr>
+        <p:spPr>
+          <a:xfrm>
+            <a:off x="9390888" y="1901952"/>
+            <a:ext cx="1920240" cy="292608"/>
+          </a:xfrm>
+          <a:prstGeom prst="rect">
+            <a:avLst/>
+          </a:prstGeom>
+          <a:noFill/>
+        </p:spPr>
+        <p:txBody>
+          <a:bodyPr wrap="none">
+            <a:spAutoFit/>
+          </a:bodyPr>
+          <a:lstStyle/>
+          <a:p>
+            <a:pPr algn="l"/>
+            <a:r>
+              <a:rPr sz="1800" b="1">
+                <a:solidFill>
+                  <a:srgbClr val="0E2340"/>
+                </a:solidFill>
+                <a:latin typeface="Aptos"/>
+              </a:rPr>
+              <a:t>Total</a:t>
+            </a:r>
+          </a:p>
+        </p:txBody>
+      </p:sp>
+      <p:sp>
+        <p:nvSpPr>
+          <p:cNvPr id="20" name="TextBox 19"/>
+          <p:cNvSpPr txBox="1"/>
+          <p:nvPr/>
+        </p:nvSpPr>
+        <p:spPr>
+          <a:xfrm>
+            <a:off x="9390888" y="2331720"/>
+            <a:ext cx="1920240" cy="932688"/>
+          </a:xfrm>
+          <a:prstGeom prst="rect">
+            <a:avLst/>
+          </a:prstGeom>
+          <a:noFill/>
+        </p:spPr>
+        <p:txBody>
+          <a:bodyPr wrap="none">
+            <a:spAutoFit/>
+          </a:bodyPr>
+          <a:lstStyle/>
+          <a:p>
+            <a:pPr algn="l"/>
+            <a:r>
+              <a:rPr sz="1400" b="0">
+                <a:solidFill>
+                  <a:srgbClr val="28313B"/>
+                </a:solidFill>
+                <a:latin typeface="Aptos"/>
+              </a:rPr>
+              <a:t>70 a 110 dias
+Sistema completo nas três etapas</a:t>
+            </a:r>
+          </a:p>
+        </p:txBody>
+      </p:sp>
+      <p:sp>
+        <p:nvSpPr>
+          <p:cNvPr id="21" name="TextBox 20"/>
+          <p:cNvSpPr txBox="1"/>
+          <p:nvPr/>
+        </p:nvSpPr>
+        <p:spPr>
+          <a:xfrm>
+            <a:off x="914400" y="3977639"/>
+            <a:ext cx="10058400" cy="1463040"/>
+          </a:xfrm>
+          <a:prstGeom prst="rect">
+            <a:avLst/>
+          </a:prstGeom>
+          <a:noFill/>
+        </p:spPr>
+        <p:txBody>
+          <a:bodyPr wrap="square">
+            <a:spAutoFit/>
+          </a:bodyPr>
+          <a:lstStyle/>
+          <a:p>
+            <a:pPr>
+              <a:spcAft>
+                <a:spcPts val="700"/>
+              </a:spcAft>
+              <a:defRPr sz="1700">
+                <a:solidFill>
+                  <a:srgbClr val="28313B"/>
+                </a:solidFill>
+                <a:latin typeface="Aptos"/>
+              </a:defRPr>
+            </a:pPr>
+            <a:r>
+              <a:t>Estimativa em dias de trabalho, não dias corridos.</a:t>
+            </a:r>
+          </a:p>
+          <a:p>
+            <a:pPr>
+              <a:spcAft>
+                <a:spcPts val="700"/>
+              </a:spcAft>
+              <a:defRPr sz="1700">
+                <a:solidFill>
+                  <a:srgbClr val="28313B"/>
+                </a:solidFill>
+                <a:latin typeface="Aptos"/>
+              </a:defRPr>
+            </a:pPr>
+            <a:r>
+              <a:t>Base de cálculo: 9 horas por dia e 5 dias por semana.</a:t>
+            </a:r>
+          </a:p>
+          <a:p>
+            <a:pPr>
+              <a:spcAft>
+                <a:spcPts val="700"/>
+              </a:spcAft>
+              <a:defRPr sz="1700">
+                <a:solidFill>
+                  <a:srgbClr val="28313B"/>
+                </a:solidFill>
+                <a:latin typeface="Aptos"/>
+              </a:defRPr>
+            </a:pPr>
+            <a:r>
+              <a:t>Varia conforme catraca/cartões, relatórios, backup, regras de caixa, SMS e gateway de pagamento.</a:t>
+            </a:r>
+          </a:p>
+          <a:p>
+            <a:pPr>
+              <a:spcAft>
+                <a:spcPts val="700"/>
+              </a:spcAft>
+              <a:defRPr sz="1700">
+                <a:solidFill>
+                  <a:srgbClr val="28313B"/>
+                </a:solidFill>
+                <a:latin typeface="Aptos"/>
+              </a:defRPr>
+            </a:pPr>
+            <a:r>
+              <a:t>A Etapa 1 deve ser tratada como MVP operacional do ginásio.</a:t>
+            </a:r>
+          </a:p>
+        </p:txBody>
+      </p:sp>
+      <p:sp>
+        <p:nvSpPr>
+          <p:cNvPr id="22" name="TextBox 21"/>
+          <p:cNvSpPr txBox="1"/>
+          <p:nvPr/>
+        </p:nvSpPr>
+        <p:spPr>
+          <a:xfrm>
+            <a:off x="11384280" y="6446520"/>
+            <a:ext cx="411480" cy="228600"/>
+          </a:xfrm>
+          <a:prstGeom prst="rect">
+            <a:avLst/>
+          </a:prstGeom>
+          <a:noFill/>
+        </p:spPr>
+        <p:txBody>
+          <a:bodyPr wrap="none">
+            <a:spAutoFit/>
+          </a:bodyPr>
+          <a:lstStyle/>
+          <a:p>
+            <a:pPr algn="r"/>
+            <a:r>
+              <a:rPr sz="900" b="0">
+                <a:solidFill>
+                  <a:srgbClr val="687480"/>
+                </a:solidFill>
+                <a:latin typeface="Aptos"/>
+              </a:rPr>
+              <a:t>20</a:t>
             </a:r>
           </a:p>
         </p:txBody>

</xml_diff>

<commit_message>
Add Portuguese accents to proposal documents
Co-authored-by: Fred Alberto Tembe <Fredalbertomoz@gmail.com>
</commit_message>
<xml_diff>
--- a/docs/sistema-gestao-ginasio-apresentacao.pptx
+++ b/docs/sistema-gestao-ginasio-apresentacao.pptx
@@ -7004,7 +7004,7 @@
                 </a:solidFill>
                 <a:latin typeface="Aptos"/>
               </a:rPr>
-              <a:t>Telas desktop, MVVM, navegação e interação do utilizador.</a:t>
+              <a:t>Telas desktop, MVVM, navegação e interáção do utilizador.</a:t>
             </a:r>
           </a:p>
         </p:txBody>
@@ -8301,7 +8301,7 @@
                 </a:solidFill>
                 <a:latin typeface="Aptos"/>
               </a:rPr>
-              <a:t>Alterações locais ficam pendentes até serem enviadas à API web.</a:t>
+              <a:t>Alteráções locais ficam pendentes até serem enviadas à API web.</a:t>
             </a:r>
           </a:p>
         </p:txBody>
@@ -8459,7 +8459,7 @@
                 </a:solidFill>
                 <a:latin typeface="Aptos"/>
               </a:rPr>
-              <a:t>A API consolida dados entre unidades e permite gestão futura pela web.</a:t>
+              <a:t>A API consólida dados entre unidades e permite gestão futura pela web.</a:t>
             </a:r>
           </a:p>
         </p:txBody>
@@ -13520,7 +13520,7 @@
                 </a:solidFill>
                 <a:latin typeface="Aptos"/>
               </a:rPr>
-              <a:t>Loja e vendas</a:t>
+              <a:t>Lojá e vendas</a:t>
             </a:r>
           </a:p>
         </p:txBody>
@@ -14748,7 +14748,7 @@
               </a:defRPr>
             </a:pPr>
             <a:r>
-              <a:t>O gestor tem visão consolidada de acessos, finanças, vendas e relatórios.</a:t>
+              <a:t>O gestor tem visão consólidada de acessos, finanças, vendas e relatórios.</a:t>
             </a:r>
           </a:p>
         </p:txBody>
@@ -16052,7 +16052,7 @@
               </a:defRPr>
             </a:pPr>
             <a:r>
-              <a:t>O sistema pode controlar renovação, reativação e histórico de alterações.</a:t>
+              <a:t>O sistema pode controlar renovação, reativação e histórico de alteráções.</a:t>
             </a:r>
           </a:p>
           <a:p>

</xml_diff>